<commit_message>
feat : change expieriences order
</commit_message>
<xml_diff>
--- a/Templates/Template_CV_format_DVT.pptx
+++ b/Templates/Template_CV_format_DVT.pptx
@@ -10451,7 +10451,7 @@
         <p:fade/>
       </p:transition>
     </mc:Choice>
-    <mc:Fallback xmlns:ahyp="http://schemas.microsoft.com/office/drawing/2018/hyperlinkcolor" xmlns:p15="http://schemas.microsoft.com/office/powerpoint/2012/main" xmlns:com="http://schemas.openxmlformats.org/drawingml/2006/compatibility" xmlns:pvml="urn:schemas-microsoft-com:office:powerpoint" xmlns:v="urn:schemas-microsoft-com:vml" xmlns:o="urn:schemas-microsoft-com:office:office" xmlns:dgm="http://schemas.openxmlformats.org/drawingml/2006/diagram" xmlns:c="http://schemas.openxmlformats.org/drawingml/2006/chart" xmlns:mv="urn:schemas-microsoft-com:mac:vml" xmlns="">
+    <mc:Fallback xmlns="" xmlns:mv="urn:schemas-microsoft-com:mac:vml" xmlns:c="http://schemas.openxmlformats.org/drawingml/2006/chart" xmlns:dgm="http://schemas.openxmlformats.org/drawingml/2006/diagram" xmlns:o="urn:schemas-microsoft-com:office:office" xmlns:v="urn:schemas-microsoft-com:vml" xmlns:pvml="urn:schemas-microsoft-com:office:powerpoint" xmlns:com="http://schemas.openxmlformats.org/drawingml/2006/compatibility" xmlns:p15="http://schemas.microsoft.com/office/powerpoint/2012/main" xmlns:ahyp="http://schemas.microsoft.com/office/drawing/2018/hyperlinkcolor">
       <p:transition spd="med">
         <p:fade/>
       </p:transition>
@@ -19073,6 +19073,226 @@
               <a:ea typeface="Montserrat SemiBold"/>
               <a:cs typeface="Montserrat SemiBold"/>
               <a:sym typeface="Montserrat SemiBold"/>
+            </a:endParaRPr>
+          </a:p>
+        </p:txBody>
+      </p:sp>
+      <p:sp>
+        <p:nvSpPr>
+          <p:cNvPr id="7" name="Google Shape;870;p91">
+            <a:extLst>
+              <a:ext uri="{FF2B5EF4-FFF2-40B4-BE49-F238E27FC236}">
+                <a16:creationId xmlns:a16="http://schemas.microsoft.com/office/drawing/2014/main" id="{065FDB89-BB88-3578-ACD5-A6107EA63616}"/>
+              </a:ext>
+            </a:extLst>
+          </p:cNvPr>
+          <p:cNvSpPr txBox="1"/>
+          <p:nvPr/>
+        </p:nvSpPr>
+        <p:spPr>
+          <a:xfrm>
+            <a:off x="3615992" y="66731"/>
+            <a:ext cx="5357100" cy="999008"/>
+          </a:xfrm>
+          <a:prstGeom prst="rect">
+            <a:avLst/>
+          </a:prstGeom>
+          <a:noFill/>
+          <a:ln>
+            <a:noFill/>
+          </a:ln>
+        </p:spPr>
+        <p:txBody>
+          <a:bodyPr spcFirstLastPara="1" wrap="square" lIns="91425" tIns="91425" rIns="91425" bIns="91425" anchor="t" anchorCtr="0">
+            <a:noAutofit/>
+          </a:bodyPr>
+          <a:lstStyle/>
+          <a:p>
+            <a:pPr marL="63499" algn="just" defTabSz="914378">
+              <a:buSzPts val="600"/>
+            </a:pPr>
+            <a:r>
+              <a:rPr lang="fr-FR" sz="800" dirty="0">
+                <a:latin typeface="Montserrat"/>
+              </a:rPr>
+              <a:t>Habiba dispose de 6 ans d’expérience dans le secteur bancaire, spécialisée dans la transformation digitale et l'optimisation des processus métiers, avec une expertise forte en </a:t>
+            </a:r>
+            <a:r>
+              <a:rPr lang="fr-FR" sz="800" b="1" dirty="0" err="1">
+                <a:latin typeface="Montserrat"/>
+              </a:rPr>
+              <a:t>Corporate</a:t>
+            </a:r>
+            <a:r>
+              <a:rPr lang="fr-FR" sz="800" b="1" dirty="0">
+                <a:latin typeface="Montserrat"/>
+              </a:rPr>
+              <a:t> </a:t>
+            </a:r>
+            <a:r>
+              <a:rPr lang="fr-FR" sz="800" b="1" dirty="0" err="1">
+                <a:latin typeface="Montserrat"/>
+              </a:rPr>
+              <a:t>Lending</a:t>
+            </a:r>
+            <a:r>
+              <a:rPr lang="fr-FR" sz="800" dirty="0">
+                <a:latin typeface="Montserrat"/>
+              </a:rPr>
+              <a:t>. Experte du cadrage à la livraison, elle combine une solide maîtrise des méthodologies Agiles et une maitrise du </a:t>
+            </a:r>
+            <a:r>
+              <a:rPr lang="fr-FR" sz="800" b="1" dirty="0">
+                <a:latin typeface="Montserrat"/>
+              </a:rPr>
+              <a:t>QA</a:t>
+            </a:r>
+            <a:r>
+              <a:rPr lang="fr-FR" sz="800" dirty="0">
+                <a:latin typeface="Montserrat"/>
+              </a:rPr>
+              <a:t> pour garantir la valeur et la conformité des solutions déployées. Habituée à collaborer étroitement avec les équipes métiers et IT, elle intervient sur des projets stratégiques à forte valeur ajoutée.</a:t>
+            </a:r>
+            <a:endParaRPr sz="800" dirty="0">
+              <a:solidFill>
+                <a:srgbClr val="595959"/>
+              </a:solidFill>
+              <a:latin typeface="Montserrat"/>
+              <a:ea typeface="Montserrat"/>
+              <a:cs typeface="Montserrat"/>
+              <a:sym typeface="Montserrat"/>
+            </a:endParaRPr>
+          </a:p>
+        </p:txBody>
+      </p:sp>
+      <p:cxnSp>
+        <p:nvCxnSpPr>
+          <p:cNvPr id="8" name="Google Shape;871;p91">
+            <a:extLst>
+              <a:ext uri="{FF2B5EF4-FFF2-40B4-BE49-F238E27FC236}">
+                <a16:creationId xmlns:a16="http://schemas.microsoft.com/office/drawing/2014/main" id="{CCA57207-63B7-01DF-A48E-1FFCD71C1E34}"/>
+              </a:ext>
+            </a:extLst>
+          </p:cNvPr>
+          <p:cNvCxnSpPr/>
+          <p:nvPr/>
+        </p:nvCxnSpPr>
+        <p:spPr>
+          <a:xfrm>
+            <a:off x="3616697" y="154850"/>
+            <a:ext cx="0" cy="686700"/>
+          </a:xfrm>
+          <a:prstGeom prst="straightConnector1">
+            <a:avLst/>
+          </a:prstGeom>
+          <a:noFill/>
+          <a:ln w="19050" cap="flat" cmpd="sng">
+            <a:solidFill>
+              <a:schemeClr val="lt2"/>
+            </a:solidFill>
+            <a:prstDash val="solid"/>
+            <a:round/>
+            <a:headEnd type="none" w="sm" len="sm"/>
+            <a:tailEnd type="none" w="sm" len="sm"/>
+          </a:ln>
+        </p:spPr>
+      </p:cxnSp>
+      <p:sp>
+        <p:nvSpPr>
+          <p:cNvPr id="12" name="Google Shape;872;p91">
+            <a:extLst>
+              <a:ext uri="{FF2B5EF4-FFF2-40B4-BE49-F238E27FC236}">
+                <a16:creationId xmlns:a16="http://schemas.microsoft.com/office/drawing/2014/main" id="{C6092E2A-6601-8861-3398-097339339D0C}"/>
+              </a:ext>
+            </a:extLst>
+          </p:cNvPr>
+          <p:cNvSpPr/>
+          <p:nvPr/>
+        </p:nvSpPr>
+        <p:spPr>
+          <a:xfrm>
+            <a:off x="1613875" y="860450"/>
+            <a:ext cx="1648500" cy="290700"/>
+          </a:xfrm>
+          <a:prstGeom prst="roundRect">
+            <a:avLst>
+              <a:gd name="adj" fmla="val 16667"/>
+            </a:avLst>
+          </a:prstGeom>
+          <a:solidFill>
+            <a:schemeClr val="lt1"/>
+          </a:solidFill>
+          <a:ln>
+            <a:noFill/>
+          </a:ln>
+          <a:effectLst>
+            <a:outerShdw blurRad="57150" dist="19050" dir="5400000" algn="bl" rotWithShape="0">
+              <a:srgbClr val="000000">
+                <a:alpha val="49411"/>
+              </a:srgbClr>
+            </a:outerShdw>
+          </a:effectLst>
+        </p:spPr>
+        <p:txBody>
+          <a:bodyPr spcFirstLastPara="1" wrap="square" lIns="91425" tIns="91425" rIns="91425" bIns="91425" anchor="ctr" anchorCtr="0">
+            <a:noAutofit/>
+          </a:bodyPr>
+          <a:lstStyle/>
+          <a:p>
+            <a:pPr algn="ctr" defTabSz="914378"/>
+            <a:r>
+              <a:rPr lang="en-GB" sz="900" b="1" dirty="0">
+                <a:solidFill>
+                  <a:srgbClr val="EB475E"/>
+                </a:solidFill>
+                <a:latin typeface="Montserrat"/>
+                <a:ea typeface="Montserrat"/>
+                <a:cs typeface="Montserrat"/>
+                <a:sym typeface="Montserrat"/>
+              </a:rPr>
+              <a:t>6 </a:t>
+            </a:r>
+            <a:r>
+              <a:rPr lang="en-GB" sz="900" b="1" dirty="0" err="1">
+                <a:solidFill>
+                  <a:srgbClr val="EB475E"/>
+                </a:solidFill>
+                <a:latin typeface="Montserrat"/>
+                <a:ea typeface="Montserrat"/>
+                <a:cs typeface="Montserrat"/>
+                <a:sym typeface="Montserrat"/>
+              </a:rPr>
+              <a:t>ans</a:t>
+            </a:r>
+            <a:r>
+              <a:rPr lang="en-GB" sz="900" b="1" dirty="0">
+                <a:solidFill>
+                  <a:srgbClr val="EB475E"/>
+                </a:solidFill>
+                <a:latin typeface="Montserrat"/>
+                <a:ea typeface="Montserrat"/>
+                <a:cs typeface="Montserrat"/>
+                <a:sym typeface="Montserrat"/>
+              </a:rPr>
+              <a:t> </a:t>
+            </a:r>
+            <a:r>
+              <a:rPr lang="en-GB" sz="900" b="1" dirty="0" err="1">
+                <a:solidFill>
+                  <a:srgbClr val="EB475E"/>
+                </a:solidFill>
+                <a:latin typeface="Montserrat"/>
+                <a:ea typeface="Montserrat"/>
+                <a:cs typeface="Montserrat"/>
+                <a:sym typeface="Montserrat"/>
+              </a:rPr>
+              <a:t>d’expérience</a:t>
+            </a:r>
+            <a:endParaRPr dirty="0">
+              <a:latin typeface="Montserrat"/>
+              <a:ea typeface="Montserrat"/>
+              <a:cs typeface="Montserrat"/>
+              <a:sym typeface="Montserrat"/>
             </a:endParaRPr>
           </a:p>
         </p:txBody>

</xml_diff>